<commit_message>
chore(slide): dung lai bo slide 20 trang va kich ban noi
slide-bao-ve.pptx: 20 slide 16:9, ca 20 slide deu co ghi chu nguoi trinh bay
nen mo che do nguoi trinh bay la thay loi noi ngay duoi slide.

kich-ban-bao-ve: them ban in duoc o thesis/doc (.docx) va thesis/pdf (6 trang)
de cam theo khi dung noi.

Co-Authored-By: Claude Opus 5 <noreply@anthropic.com>
Claude-Session: https://claude.ai/code/session_01AEgUuwxWZb75UPoWigF6iK
</commit_message>
<xml_diff>
--- a/thesis/abs/slide-bao-ve.pptx
+++ b/thesis/abs/slide-bao-ve.pptx
@@ -1011,7 +1011,7 @@
           <a:lstStyle/>
           <a:p>
             <a:r>
-              <a:t>Kiểm thử tích hợp chạy trên PostgreSQL thật qua Testcontainers, vì ràng buộc loại trừ là tính năng của PostgreSQL — giả lập bằng cơ sở dữ liệu trong bộ nhớ thì đúng thứ cần kiểm lại không tồn tại.</a:t>
+              <a:t>Kiểm thử tích hợp chạy trên PostgreSQL thật qua Testcontainers, vì ràng buộc loại trừ là tính năng của PostgreSQL — giả lập bằng cơ sở dữ liệu trong bộ nhớ thì đúng thứ cần kiểm lại không tồn tại. Nếu thầy cô hỏi: lần chạy đầy đủ gần nhất xanh 129 ca; bảy ca của lớp kiểm thử nút mô phỏng chuyển khoản bổ sung sau đó em mới kiểm chứng bằng cách gọi trực tiếp qua HTTP, chưa qua một lần chạy đầy đủ cả 136 ca.</a:t>
             </a:r>
           </a:p>
         </p:txBody>
@@ -1081,7 +1081,7 @@
           <a:lstStyle/>
           <a:p>
             <a:r>
-              <a:t>Quét tự động ngay trên bản đóng gói đang chạy, đi qua đúng máy chủ web và đúng chính sách bảo mật nội dung của bản triển khai.</a:t>
+              <a:t>Bảng trên slide là kết quả quét thật, không phải con số em tự ghi: mỗi dòng là một màn hình, cột giữa là số vi phạm. Quét ngay trên bản đóng gói đang chạy, đi qua đúng máy chủ web và đúng chính sách bảo mật nội dung của bản triển khai.</a:t>
             </a:r>
           </a:p>
         </p:txBody>
@@ -4853,7 +4853,7 @@
     <p:bg>
       <p:bgPr>
         <a:solidFill>
-          <a:srgbClr val="0F5C4C"/>
+          <a:srgbClr val="0E5C63"/>
         </a:solidFill>
         <a:effectLst/>
       </p:bgPr>
@@ -4964,7 +4964,7 @@
                 </a:solidFill>
                 <a:latin typeface="Times New Roman"/>
               </a:rPr>
-              <a:t>VÀ ĐẶT PHÒNG HOMESTAY TVH</a:t>
+              <a:t>VÀ ĐẶT PHÒNG HOMESTAY – HOMESTAY TVH</a:t>
             </a:r>
           </a:p>
           <a:p>
@@ -4980,7 +4980,7 @@
                 </a:solidFill>
                 <a:latin typeface="Times New Roman"/>
               </a:rPr>
-              <a:t>Giảng viên hướng dẫn:  . . . . . . . . . . . . . . . . . . . .</a:t>
+              <a:t>Giảng viên hướng dẫn:  ThS. Nguyễn Nhứt Lam</a:t>
             </a:r>
           </a:p>
           <a:p>
@@ -4996,7 +4996,7 @@
                 </a:solidFill>
                 <a:latin typeface="Times New Roman"/>
               </a:rPr>
-              <a:t>Sinh viên thực hiện:  . . . . . . . . . . . . . . . . . . . .</a:t>
+              <a:t>Sinh viên thực hiện:  Nguyễn Hồng Quân</a:t>
             </a:r>
           </a:p>
           <a:p>
@@ -5012,7 +5012,7 @@
                 </a:solidFill>
                 <a:latin typeface="Times New Roman"/>
               </a:rPr>
-              <a:t>Mã số sinh viên:  . . . . . . . . . . .      Lớp:  . . . . . . . . . . .</a:t>
+              <a:t>Mã số sinh viên:  170123592      Lớp:  DX23TT11</a:t>
             </a:r>
           </a:p>
         </p:txBody>
@@ -5058,7 +5058,7 @@
             <a:avLst/>
           </a:prstGeom>
           <a:solidFill>
-            <a:srgbClr val="0F5C4C"/>
+            <a:srgbClr val="0E5C63"/>
           </a:solidFill>
           <a:ln>
             <a:noFill/>
@@ -5111,7 +5111,7 @@
             <a:r>
               <a:rPr sz="4000" b="1" i="0">
                 <a:solidFill>
-                  <a:srgbClr val="0F5C4C"/>
+                  <a:srgbClr val="0E5C63"/>
                 </a:solidFill>
                 <a:latin typeface="Times New Roman"/>
               </a:rPr>
@@ -5150,7 +5150,7 @@
             <a:r>
               <a:rPr sz="3200" b="0" i="0">
                 <a:solidFill>
-                  <a:srgbClr val="1C1917"/>
+                  <a:srgbClr val="1A1A17"/>
                 </a:solidFill>
                 <a:latin typeface="Times New Roman"/>
               </a:rPr>
@@ -5166,7 +5166,7 @@
             <a:r>
               <a:rPr sz="3200" b="0" i="0">
                 <a:solidFill>
-                  <a:srgbClr val="1C1917"/>
+                  <a:srgbClr val="1A1A17"/>
                 </a:solidFill>
                 <a:latin typeface="Times New Roman"/>
               </a:rPr>
@@ -5182,7 +5182,7 @@
             <a:r>
               <a:rPr sz="3200" b="0" i="0">
                 <a:solidFill>
-                  <a:srgbClr val="1C1917"/>
+                  <a:srgbClr val="1A1A17"/>
                 </a:solidFill>
                 <a:latin typeface="Times New Roman"/>
               </a:rPr>
@@ -5198,7 +5198,7 @@
             <a:r>
               <a:rPr sz="3200" b="0" i="0">
                 <a:solidFill>
-                  <a:srgbClr val="1C1917"/>
+                  <a:srgbClr val="1A1A17"/>
                 </a:solidFill>
                 <a:latin typeface="Times New Roman"/>
               </a:rPr>
@@ -5248,7 +5248,7 @@
             <a:avLst/>
           </a:prstGeom>
           <a:solidFill>
-            <a:srgbClr val="0F5C4C"/>
+            <a:srgbClr val="0E5C63"/>
           </a:solidFill>
           <a:ln>
             <a:noFill/>
@@ -5301,11 +5301,11 @@
             <a:r>
               <a:rPr sz="4000" b="1" i="0">
                 <a:solidFill>
-                  <a:srgbClr val="0F5C4C"/>
+                  <a:srgbClr val="0E5C63"/>
                 </a:solidFill>
                 <a:latin typeface="Times New Roman"/>
               </a:rPr>
-              <a:t>Cơ sở dữ liệu: 21 bảng, 8 migration</a:t>
+              <a:t>Cơ sở dữ liệu: 21 bảng, 9 migration</a:t>
             </a:r>
           </a:p>
         </p:txBody>
@@ -5375,7 +5375,7 @@
             <a:avLst/>
           </a:prstGeom>
           <a:solidFill>
-            <a:srgbClr val="0F5C4C"/>
+            <a:srgbClr val="0E5C63"/>
           </a:solidFill>
           <a:ln>
             <a:noFill/>
@@ -5428,7 +5428,7 @@
             <a:r>
               <a:rPr sz="4400" b="1" i="0">
                 <a:solidFill>
-                  <a:srgbClr val="0F5C4C"/>
+                  <a:srgbClr val="0E5C63"/>
                 </a:solidFill>
                 <a:latin typeface="Times New Roman"/>
               </a:rPr>
@@ -5502,7 +5502,7 @@
             <a:avLst/>
           </a:prstGeom>
           <a:solidFill>
-            <a:srgbClr val="0F5C4C"/>
+            <a:srgbClr val="0E5C63"/>
           </a:solidFill>
           <a:ln>
             <a:noFill/>
@@ -5555,7 +5555,7 @@
             <a:r>
               <a:rPr sz="4400" b="1" i="0">
                 <a:solidFill>
-                  <a:srgbClr val="0F5C4C"/>
+                  <a:srgbClr val="0E5C63"/>
                 </a:solidFill>
                 <a:latin typeface="Times New Roman"/>
               </a:rPr>
@@ -5629,7 +5629,7 @@
             <a:avLst/>
           </a:prstGeom>
           <a:solidFill>
-            <a:srgbClr val="0F5C4C"/>
+            <a:srgbClr val="0E5C63"/>
           </a:solidFill>
           <a:ln>
             <a:noFill/>
@@ -5682,7 +5682,7 @@
             <a:r>
               <a:rPr sz="4000" b="1" i="0">
                 <a:solidFill>
-                  <a:srgbClr val="0F5C4C"/>
+                  <a:srgbClr val="0E5C63"/>
                 </a:solidFill>
                 <a:latin typeface="Times New Roman"/>
               </a:rPr>
@@ -5693,7 +5693,7 @@
       </p:sp>
       <p:pic>
         <p:nvPicPr>
-          <p:cNvPr id="4" name="Picture 3" descr="hinh-3-14-ba-buoc-dat-phong.png"/>
+          <p:cNvPr id="4" name="Picture 3" descr="hinh-3-11-ba-buoc-dat-phong.png"/>
           <p:cNvPicPr>
             <a:picLocks noChangeAspect="1"/>
           </p:cNvPicPr>
@@ -5707,8 +5707,8 @@
         </p:blipFill>
         <p:spPr>
           <a:xfrm>
-            <a:off x="1080000" y="2380410"/>
-            <a:ext cx="10033200" cy="3177179"/>
+            <a:off x="1080000" y="2735752"/>
+            <a:ext cx="10033200" cy="2466495"/>
           </a:xfrm>
           <a:prstGeom prst="rect">
             <a:avLst/>
@@ -5756,7 +5756,7 @@
             <a:avLst/>
           </a:prstGeom>
           <a:solidFill>
-            <a:srgbClr val="0F5C4C"/>
+            <a:srgbClr val="0E5C63"/>
           </a:solidFill>
           <a:ln>
             <a:noFill/>
@@ -5809,7 +5809,7 @@
             <a:r>
               <a:rPr sz="4400" b="1" i="0">
                 <a:solidFill>
-                  <a:srgbClr val="0F5C4C"/>
+                  <a:srgbClr val="0E5C63"/>
                 </a:solidFill>
                 <a:latin typeface="Times New Roman"/>
               </a:rPr>
@@ -5820,7 +5820,7 @@
       </p:sp>
       <p:pic>
         <p:nvPicPr>
-          <p:cNvPr id="4" name="Picture 3" descr="hinh-3-16-dashboard.png"/>
+          <p:cNvPr id="4" name="Picture 3" descr="hinh-3-13-dashboard.png"/>
           <p:cNvPicPr>
             <a:picLocks noChangeAspect="1"/>
           </p:cNvPicPr>
@@ -5883,7 +5883,7 @@
             <a:avLst/>
           </a:prstGeom>
           <a:solidFill>
-            <a:srgbClr val="0F5C4C"/>
+            <a:srgbClr val="0E5C63"/>
           </a:solidFill>
           <a:ln>
             <a:noFill/>
@@ -5936,7 +5936,7 @@
             <a:r>
               <a:rPr sz="4400" b="1" i="0">
                 <a:solidFill>
-                  <a:srgbClr val="0F5C4C"/>
+                  <a:srgbClr val="0E5C63"/>
                 </a:solidFill>
                 <a:latin typeface="Times New Roman"/>
               </a:rPr>
@@ -5975,11 +5975,11 @@
             <a:r>
               <a:rPr sz="3200" b="0" i="0">
                 <a:solidFill>
-                  <a:srgbClr val="1C1917"/>
+                  <a:srgbClr val="1A1A17"/>
                 </a:solidFill>
                 <a:latin typeface="Times New Roman"/>
               </a:rPr>
-              <a:t>▪  129 ca kiểm thử, tất cả đạt</a:t>
+              <a:t>▪  136 ca kiểm thử trong 19 lớp</a:t>
             </a:r>
           </a:p>
           <a:p>
@@ -5991,7 +5991,7 @@
             <a:r>
               <a:rPr sz="3200" b="0" i="0">
                 <a:solidFill>
-                  <a:srgbClr val="1C1917"/>
+                  <a:srgbClr val="1A1A17"/>
                 </a:solidFill>
                 <a:latin typeface="Times New Roman"/>
               </a:rPr>
@@ -6007,7 +6007,7 @@
             <a:r>
               <a:rPr sz="3200" b="0" i="0">
                 <a:solidFill>
-                  <a:srgbClr val="1C1917"/>
+                  <a:srgbClr val="1A1A17"/>
                 </a:solidFill>
                 <a:latin typeface="Times New Roman"/>
               </a:rPr>
@@ -6023,7 +6023,7 @@
             <a:r>
               <a:rPr sz="3200" b="0" i="0">
                 <a:solidFill>
-                  <a:srgbClr val="1C1917"/>
+                  <a:srgbClr val="1A1A17"/>
                 </a:solidFill>
                 <a:latin typeface="Times New Roman"/>
               </a:rPr>
@@ -6073,7 +6073,7 @@
             <a:avLst/>
           </a:prstGeom>
           <a:solidFill>
-            <a:srgbClr val="0F5C4C"/>
+            <a:srgbClr val="0E5C63"/>
           </a:solidFill>
           <a:ln>
             <a:noFill/>
@@ -6126,7 +6126,7 @@
             <a:r>
               <a:rPr sz="4400" b="1" i="0">
                 <a:solidFill>
-                  <a:srgbClr val="0F5C4C"/>
+                  <a:srgbClr val="0E5C63"/>
                 </a:solidFill>
                 <a:latin typeface="Times New Roman"/>
               </a:rPr>
@@ -6165,11 +6165,11 @@
             <a:r>
               <a:rPr sz="2800" b="0" i="0">
                 <a:solidFill>
-                  <a:srgbClr val="1C1917"/>
+                  <a:srgbClr val="1A1A17"/>
                 </a:solidFill>
                 <a:latin typeface="Times New Roman"/>
               </a:rPr>
-              <a:t>▪  Quét 17 màn hình: 0 vi phạm WCAG 2.1 mức A và AA</a:t>
+              <a:t>▪  Quét 17 màn hình: 0 vi phạm WCAG 2.1 mức A và AA, 353 lần quy tắc đạt</a:t>
             </a:r>
           </a:p>
           <a:p>
@@ -6181,7 +6181,7 @@
             <a:r>
               <a:rPr sz="2800" b="0" i="0">
                 <a:solidFill>
-                  <a:srgbClr val="1C1917"/>
+                  <a:srgbClr val="1A1A17"/>
                 </a:solidFill>
                 <a:latin typeface="Times New Roman"/>
               </a:rPr>
@@ -6197,7 +6197,7 @@
             <a:r>
               <a:rPr sz="2800" b="0" i="0">
                 <a:solidFill>
-                  <a:srgbClr val="1C1917"/>
+                  <a:srgbClr val="1A1A17"/>
                 </a:solidFill>
                 <a:latin typeface="Times New Roman"/>
               </a:rPr>
@@ -6208,7 +6208,7 @@
       </p:sp>
       <p:pic>
         <p:nvPicPr>
-          <p:cNvPr id="5" name="Picture 4" descr="hinh-3-20-docker-compose-ps.png"/>
+          <p:cNvPr id="5" name="Picture 4" descr="hinh-4-2-quet-kha-nang-tiep-can.png"/>
           <p:cNvPicPr>
             <a:picLocks noChangeAspect="1"/>
           </p:cNvPicPr>
@@ -6222,8 +6222,8 @@
         </p:blipFill>
         <p:spPr>
           <a:xfrm>
-            <a:off x="6120000" y="3530058"/>
-            <a:ext cx="5472000" cy="877882"/>
+            <a:off x="6120000" y="2416074"/>
+            <a:ext cx="5472000" cy="3105850"/>
           </a:xfrm>
           <a:prstGeom prst="rect">
             <a:avLst/>
@@ -6271,7 +6271,7 @@
             <a:avLst/>
           </a:prstGeom>
           <a:solidFill>
-            <a:srgbClr val="0F5C4C"/>
+            <a:srgbClr val="0E5C63"/>
           </a:solidFill>
           <a:ln>
             <a:noFill/>
@@ -6324,7 +6324,7 @@
             <a:r>
               <a:rPr sz="4400" b="1" i="0">
                 <a:solidFill>
-                  <a:srgbClr val="0F5C4C"/>
+                  <a:srgbClr val="0E5C63"/>
                 </a:solidFill>
                 <a:latin typeface="Times New Roman"/>
               </a:rPr>
@@ -6363,7 +6363,7 @@
             <a:r>
               <a:rPr sz="3200" b="0" i="0">
                 <a:solidFill>
-                  <a:srgbClr val="1C1917"/>
+                  <a:srgbClr val="1A1A17"/>
                 </a:solidFill>
                 <a:latin typeface="Times New Roman"/>
               </a:rPr>
@@ -6379,7 +6379,7 @@
             <a:r>
               <a:rPr sz="3200" b="0" i="0">
                 <a:solidFill>
-                  <a:srgbClr val="1C1917"/>
+                  <a:srgbClr val="1A1A17"/>
                 </a:solidFill>
                 <a:latin typeface="Times New Roman"/>
               </a:rPr>
@@ -6395,7 +6395,7 @@
             <a:r>
               <a:rPr sz="3200" b="0" i="0">
                 <a:solidFill>
-                  <a:srgbClr val="1C1917"/>
+                  <a:srgbClr val="1A1A17"/>
                 </a:solidFill>
                 <a:latin typeface="Times New Roman"/>
               </a:rPr>
@@ -6445,7 +6445,7 @@
             <a:avLst/>
           </a:prstGeom>
           <a:solidFill>
-            <a:srgbClr val="0F5C4C"/>
+            <a:srgbClr val="0E5C63"/>
           </a:solidFill>
           <a:ln>
             <a:noFill/>
@@ -6498,7 +6498,7 @@
             <a:r>
               <a:rPr sz="4400" b="1" i="0">
                 <a:solidFill>
-                  <a:srgbClr val="0F5C4C"/>
+                  <a:srgbClr val="0E5C63"/>
                 </a:solidFill>
                 <a:latin typeface="Times New Roman"/>
               </a:rPr>
@@ -6537,7 +6537,7 @@
             <a:r>
               <a:rPr sz="3200" b="0" i="0">
                 <a:solidFill>
-                  <a:srgbClr val="1C1917"/>
+                  <a:srgbClr val="1A1A17"/>
                 </a:solidFill>
                 <a:latin typeface="Times New Roman"/>
               </a:rPr>
@@ -6553,7 +6553,7 @@
             <a:r>
               <a:rPr sz="3200" b="0" i="0">
                 <a:solidFill>
-                  <a:srgbClr val="1C1917"/>
+                  <a:srgbClr val="1A1A17"/>
                 </a:solidFill>
                 <a:latin typeface="Times New Roman"/>
               </a:rPr>
@@ -6569,7 +6569,7 @@
             <a:r>
               <a:rPr sz="3200" b="0" i="0">
                 <a:solidFill>
-                  <a:srgbClr val="1C1917"/>
+                  <a:srgbClr val="1A1A17"/>
                 </a:solidFill>
                 <a:latin typeface="Times New Roman"/>
               </a:rPr>
@@ -6619,7 +6619,7 @@
             <a:avLst/>
           </a:prstGeom>
           <a:solidFill>
-            <a:srgbClr val="0F5C4C"/>
+            <a:srgbClr val="0E5C63"/>
           </a:solidFill>
           <a:ln>
             <a:noFill/>
@@ -6672,7 +6672,7 @@
             <a:r>
               <a:rPr sz="4400" b="1" i="0">
                 <a:solidFill>
-                  <a:srgbClr val="0F5C4C"/>
+                  <a:srgbClr val="0E5C63"/>
                 </a:solidFill>
                 <a:latin typeface="Times New Roman"/>
               </a:rPr>
@@ -6711,7 +6711,7 @@
             <a:r>
               <a:rPr sz="3200" b="0" i="0">
                 <a:solidFill>
-                  <a:srgbClr val="1C1917"/>
+                  <a:srgbClr val="1A1A17"/>
                 </a:solidFill>
                 <a:latin typeface="Times New Roman"/>
               </a:rPr>
@@ -6727,7 +6727,7 @@
             <a:r>
               <a:rPr sz="3200" b="0" i="0">
                 <a:solidFill>
-                  <a:srgbClr val="1C1917"/>
+                  <a:srgbClr val="1A1A17"/>
                 </a:solidFill>
                 <a:latin typeface="Times New Roman"/>
               </a:rPr>
@@ -6743,7 +6743,7 @@
             <a:r>
               <a:rPr sz="3200" b="0" i="0">
                 <a:solidFill>
-                  <a:srgbClr val="1C1917"/>
+                  <a:srgbClr val="1A1A17"/>
                 </a:solidFill>
                 <a:latin typeface="Times New Roman"/>
               </a:rPr>
@@ -6759,7 +6759,7 @@
             <a:r>
               <a:rPr sz="3200" b="0" i="0">
                 <a:solidFill>
-                  <a:srgbClr val="1C1917"/>
+                  <a:srgbClr val="1A1A17"/>
                 </a:solidFill>
                 <a:latin typeface="Times New Roman"/>
               </a:rPr>
@@ -6775,7 +6775,7 @@
             <a:r>
               <a:rPr sz="3200" b="0" i="0">
                 <a:solidFill>
-                  <a:srgbClr val="1C1917"/>
+                  <a:srgbClr val="1A1A17"/>
                 </a:solidFill>
                 <a:latin typeface="Times New Roman"/>
               </a:rPr>
@@ -6798,7 +6798,7 @@
     <p:bg>
       <p:bgPr>
         <a:solidFill>
-          <a:srgbClr val="0F5C4C"/>
+          <a:srgbClr val="0E5C63"/>
         </a:solidFill>
         <a:effectLst/>
       </p:bgPr>
@@ -6902,7 +6902,7 @@
             <a:avLst/>
           </a:prstGeom>
           <a:solidFill>
-            <a:srgbClr val="0F5C4C"/>
+            <a:srgbClr val="0E5C63"/>
           </a:solidFill>
           <a:ln>
             <a:noFill/>
@@ -6955,7 +6955,7 @@
             <a:r>
               <a:rPr sz="3600" b="1" i="0">
                 <a:solidFill>
-                  <a:srgbClr val="0F5C4C"/>
+                  <a:srgbClr val="0E5C63"/>
                 </a:solidFill>
                 <a:latin typeface="Times New Roman"/>
               </a:rPr>
@@ -6994,7 +6994,7 @@
             <a:r>
               <a:rPr sz="2800" b="0" i="0">
                 <a:solidFill>
-                  <a:srgbClr val="1C1917"/>
+                  <a:srgbClr val="1A1A17"/>
                 </a:solidFill>
                 <a:latin typeface="Times New Roman"/>
               </a:rPr>
@@ -7010,7 +7010,7 @@
             <a:r>
               <a:rPr sz="2800" b="0" i="0">
                 <a:solidFill>
-                  <a:srgbClr val="1C1917"/>
+                  <a:srgbClr val="1A1A17"/>
                 </a:solidFill>
                 <a:latin typeface="Times New Roman"/>
               </a:rPr>
@@ -7026,7 +7026,7 @@
             <a:r>
               <a:rPr sz="2800" b="0" i="0">
                 <a:solidFill>
-                  <a:srgbClr val="1C1917"/>
+                  <a:srgbClr val="1A1A17"/>
                 </a:solidFill>
                 <a:latin typeface="Times New Roman"/>
               </a:rPr>
@@ -7051,8 +7051,8 @@
         </p:blipFill>
         <p:spPr>
           <a:xfrm>
-            <a:off x="7750406" y="1584000"/>
-            <a:ext cx="2211187" cy="4770000"/>
+            <a:off x="6120000" y="2664840"/>
+            <a:ext cx="5472000" cy="2608320"/>
           </a:xfrm>
           <a:prstGeom prst="rect">
             <a:avLst/>
@@ -7100,7 +7100,7 @@
             <a:avLst/>
           </a:prstGeom>
           <a:solidFill>
-            <a:srgbClr val="0F5C4C"/>
+            <a:srgbClr val="0E5C63"/>
           </a:solidFill>
           <a:ln>
             <a:noFill/>
@@ -7153,7 +7153,7 @@
             <a:r>
               <a:rPr sz="3600" b="1" i="0">
                 <a:solidFill>
-                  <a:srgbClr val="0F5C4C"/>
+                  <a:srgbClr val="0E5C63"/>
                 </a:solidFill>
                 <a:latin typeface="Times New Roman"/>
               </a:rPr>
@@ -7192,7 +7192,7 @@
             <a:r>
               <a:rPr sz="3200" b="0" i="0">
                 <a:solidFill>
-                  <a:srgbClr val="1C1917"/>
+                  <a:srgbClr val="1A1A17"/>
                 </a:solidFill>
                 <a:latin typeface="Times New Roman"/>
               </a:rPr>
@@ -7208,7 +7208,7 @@
             <a:r>
               <a:rPr sz="3200" b="0" i="0">
                 <a:solidFill>
-                  <a:srgbClr val="1C1917"/>
+                  <a:srgbClr val="1A1A17"/>
                 </a:solidFill>
                 <a:latin typeface="Times New Roman"/>
               </a:rPr>
@@ -7224,7 +7224,7 @@
             <a:r>
               <a:rPr sz="3200" b="0" i="0">
                 <a:solidFill>
-                  <a:srgbClr val="1C1917"/>
+                  <a:srgbClr val="1A1A17"/>
                 </a:solidFill>
                 <a:latin typeface="Times New Roman"/>
               </a:rPr>
@@ -7274,7 +7274,7 @@
             <a:avLst/>
           </a:prstGeom>
           <a:solidFill>
-            <a:srgbClr val="0F5C4C"/>
+            <a:srgbClr val="0E5C63"/>
           </a:solidFill>
           <a:ln>
             <a:noFill/>
@@ -7327,7 +7327,7 @@
             <a:r>
               <a:rPr sz="4400" b="1" i="0">
                 <a:solidFill>
-                  <a:srgbClr val="0F5C4C"/>
+                  <a:srgbClr val="0E5C63"/>
                 </a:solidFill>
                 <a:latin typeface="Times New Roman"/>
               </a:rPr>
@@ -7366,7 +7366,7 @@
             <a:r>
               <a:rPr sz="2800" b="0" i="0">
                 <a:solidFill>
-                  <a:srgbClr val="1C1917"/>
+                  <a:srgbClr val="1A1A17"/>
                 </a:solidFill>
                 <a:latin typeface="Times New Roman"/>
               </a:rPr>
@@ -7382,7 +7382,7 @@
             <a:r>
               <a:rPr sz="2800" b="0" i="0">
                 <a:solidFill>
-                  <a:srgbClr val="1C1917"/>
+                  <a:srgbClr val="1A1A17"/>
                 </a:solidFill>
                 <a:latin typeface="Times New Roman"/>
               </a:rPr>
@@ -7398,7 +7398,7 @@
             <a:r>
               <a:rPr sz="2800" b="0" i="0">
                 <a:solidFill>
-                  <a:srgbClr val="1C1917"/>
+                  <a:srgbClr val="1A1A17"/>
                 </a:solidFill>
                 <a:latin typeface="Times New Roman"/>
               </a:rPr>
@@ -7472,7 +7472,7 @@
             <a:avLst/>
           </a:prstGeom>
           <a:solidFill>
-            <a:srgbClr val="0F5C4C"/>
+            <a:srgbClr val="0E5C63"/>
           </a:solidFill>
           <a:ln>
             <a:noFill/>
@@ -7525,7 +7525,7 @@
             <a:r>
               <a:rPr sz="4400" b="1" i="0">
                 <a:solidFill>
-                  <a:srgbClr val="0F5C4C"/>
+                  <a:srgbClr val="0E5C63"/>
                 </a:solidFill>
                 <a:latin typeface="Times New Roman"/>
               </a:rPr>
@@ -7564,7 +7564,7 @@
             <a:r>
               <a:rPr sz="3200" b="0" i="0">
                 <a:solidFill>
-                  <a:srgbClr val="1C1917"/>
+                  <a:srgbClr val="1A1A17"/>
                 </a:solidFill>
                 <a:latin typeface="Times New Roman"/>
               </a:rPr>
@@ -7580,7 +7580,7 @@
             <a:r>
               <a:rPr sz="3200" b="0" i="0">
                 <a:solidFill>
-                  <a:srgbClr val="1C1917"/>
+                  <a:srgbClr val="1A1A17"/>
                 </a:solidFill>
                 <a:latin typeface="Times New Roman"/>
               </a:rPr>
@@ -7596,7 +7596,7 @@
             <a:r>
               <a:rPr sz="3200" b="0" i="0">
                 <a:solidFill>
-                  <a:srgbClr val="1C1917"/>
+                  <a:srgbClr val="1A1A17"/>
                 </a:solidFill>
                 <a:latin typeface="Times New Roman"/>
               </a:rPr>
@@ -7612,7 +7612,7 @@
             <a:r>
               <a:rPr sz="3200" b="0" i="0">
                 <a:solidFill>
-                  <a:srgbClr val="1C1917"/>
+                  <a:srgbClr val="1A1A17"/>
                 </a:solidFill>
                 <a:latin typeface="Times New Roman"/>
               </a:rPr>
@@ -7662,7 +7662,7 @@
             <a:avLst/>
           </a:prstGeom>
           <a:solidFill>
-            <a:srgbClr val="0F5C4C"/>
+            <a:srgbClr val="0E5C63"/>
           </a:solidFill>
           <a:ln>
             <a:noFill/>
@@ -7715,7 +7715,7 @@
             <a:r>
               <a:rPr sz="4400" b="1" i="0">
                 <a:solidFill>
-                  <a:srgbClr val="0F5C4C"/>
+                  <a:srgbClr val="0E5C63"/>
                 </a:solidFill>
                 <a:latin typeface="Times New Roman"/>
               </a:rPr>
@@ -7754,7 +7754,7 @@
             <a:r>
               <a:rPr sz="3200" b="0" i="0">
                 <a:solidFill>
-                  <a:srgbClr val="1C1917"/>
+                  <a:srgbClr val="1A1A17"/>
                 </a:solidFill>
                 <a:latin typeface="Times New Roman"/>
               </a:rPr>
@@ -7770,7 +7770,7 @@
             <a:r>
               <a:rPr sz="3200" b="0" i="0">
                 <a:solidFill>
-                  <a:srgbClr val="1C1917"/>
+                  <a:srgbClr val="1A1A17"/>
                 </a:solidFill>
                 <a:latin typeface="Times New Roman"/>
               </a:rPr>
@@ -7786,7 +7786,7 @@
             <a:r>
               <a:rPr sz="3200" b="0" i="0">
                 <a:solidFill>
-                  <a:srgbClr val="1C1917"/>
+                  <a:srgbClr val="1A1A17"/>
                 </a:solidFill>
                 <a:latin typeface="Times New Roman"/>
               </a:rPr>
@@ -7802,7 +7802,7 @@
             <a:r>
               <a:rPr sz="3200" b="0" i="0">
                 <a:solidFill>
-                  <a:srgbClr val="1C1917"/>
+                  <a:srgbClr val="1A1A17"/>
                 </a:solidFill>
                 <a:latin typeface="Times New Roman"/>
               </a:rPr>
@@ -7852,7 +7852,7 @@
             <a:avLst/>
           </a:prstGeom>
           <a:solidFill>
-            <a:srgbClr val="0F5C4C"/>
+            <a:srgbClr val="0E5C63"/>
           </a:solidFill>
           <a:ln>
             <a:noFill/>
@@ -7905,7 +7905,7 @@
             <a:r>
               <a:rPr sz="4400" b="1" i="0">
                 <a:solidFill>
-                  <a:srgbClr val="0F5C4C"/>
+                  <a:srgbClr val="0E5C63"/>
                 </a:solidFill>
                 <a:latin typeface="Times New Roman"/>
               </a:rPr>
@@ -7979,7 +7979,7 @@
             <a:avLst/>
           </a:prstGeom>
           <a:solidFill>
-            <a:srgbClr val="0F5C4C"/>
+            <a:srgbClr val="0E5C63"/>
           </a:solidFill>
           <a:ln>
             <a:noFill/>
@@ -8032,7 +8032,7 @@
             <a:r>
               <a:rPr sz="4000" b="1" i="0">
                 <a:solidFill>
-                  <a:srgbClr val="0F5C4C"/>
+                  <a:srgbClr val="0E5C63"/>
                 </a:solidFill>
                 <a:latin typeface="Times New Roman"/>
               </a:rPr>
@@ -8071,7 +8071,7 @@
             <a:r>
               <a:rPr sz="2800" b="0" i="0">
                 <a:solidFill>
-                  <a:srgbClr val="1C1917"/>
+                  <a:srgbClr val="1A1A17"/>
                 </a:solidFill>
                 <a:latin typeface="Times New Roman"/>
               </a:rPr>
@@ -8087,7 +8087,7 @@
             <a:r>
               <a:rPr sz="2800" b="0" i="0">
                 <a:solidFill>
-                  <a:srgbClr val="1C1917"/>
+                  <a:srgbClr val="1A1A17"/>
                 </a:solidFill>
                 <a:latin typeface="Times New Roman"/>
               </a:rPr>
@@ -8103,7 +8103,7 @@
             <a:r>
               <a:rPr sz="2800" b="0" i="0">
                 <a:solidFill>
-                  <a:srgbClr val="1C1917"/>
+                  <a:srgbClr val="1A1A17"/>
                 </a:solidFill>
                 <a:latin typeface="Times New Roman"/>
               </a:rPr>
@@ -8119,7 +8119,7 @@
             <a:r>
               <a:rPr sz="2800" b="0" i="0">
                 <a:solidFill>
-                  <a:srgbClr val="1C1917"/>
+                  <a:srgbClr val="1A1A17"/>
                 </a:solidFill>
                 <a:latin typeface="Times New Roman"/>
               </a:rPr>

</xml_diff>